<commit_message>
docs: v1.9.0 error contract, quality metadata and power units
</commit_message>
<xml_diff>
--- a/launch/talk/ESML-MMPROPS-20min.pptx
+++ b/launch/talk/ESML-MMPROPS-20min.pptx
@@ -8568,7 +8568,7 @@
                 <a:latin typeface="DejaVu Sans Mono"/>
                 <a:ea typeface="DejaVu Sans Mono"/>
               </a:rPr>
-              <a:t>tar -xzf esml-academic-1.8.0-linux-x86_64.tar.gz</a:t>
+              <a:t>tar -xzf esml-academic-1.9.0-linux-x86_64.tar.gz</a:t>
             </a:r>
           </a:p>
           <a:p>
@@ -8588,7 +8588,7 @@
                 <a:latin typeface="DejaVu Sans Mono"/>
                 <a:ea typeface="DejaVu Sans Mono"/>
               </a:rPr>
-              <a:t>export ESML_HOME=$PWD/esml-academic-1.8.0-linux-x86_64</a:t>
+              <a:t>export ESML_HOME=$PWD/esml-academic-1.9.0-linux-x86_64</a:t>
             </a:r>
           </a:p>
           <a:p>

</xml_diff>